<commit_message>
Use Mrs. Teske's full name in the purpose statement
Co-Authored-By: Claude Opus 5.5 <noreply@anthropic.com>
Claude-Session: https://claude.ai/code/session_01XxaKdzJdgg9PZDJGp43nnJ
</commit_message>
<xml_diff>
--- a/tribute-speech/Tribute_Speech_Mrs_Teske.pptx
+++ b/tribute-speech/Tribute_Speech_Mrs_Teske.pptx
@@ -111,19 +111,19 @@
   <p:extLst>
     <p:ext uri="{521415D9-36F7-43E2-AB2F-B90AF26B5E84}">
       <p14:sectionLst xmlns:p14="http://schemas.microsoft.com/office/powerpoint/2010/main">
-        <p14:section name="Introduction" id="{e3eb4af4-23b2-a2a2-125e-ca2cedb2e575}">
+        <p14:section name="Introduction" id="{3e46b482-0948-d77b-3f03-e87769bb9fa6}">
           <p14:sldIdLst>
             <p14:sldId id="256"/>
           </p14:sldIdLst>
         </p14:section>
-        <p14:section name="Body" id="{44d70127-f651-bc30-c23c-102a78f6227f}">
+        <p14:section name="Body" id="{6414ccf3-af87-d3b4-455b-0279f1feed9c}">
           <p14:sldIdLst>
             <p14:sldId id="257"/>
             <p14:sldId id="258"/>
             <p14:sldId id="259"/>
           </p14:sldIdLst>
         </p14:section>
-        <p14:section name="Conclusion" id="{372cdb35-633e-9775-15b2-31ba714a92f5}">
+        <p14:section name="Conclusion" id="{d261a4e3-e20f-db28-ac9e-b47a2cc8a31a}">
           <p14:sldIdLst>
             <p14:sldId id="260"/>
           </p14:sldIdLst>
@@ -535,7 +535,7 @@
               <a:t>INTRO
 Imagine you are stuck on a homework problem. You walk up to the teacher's desk to ask for help. But the second you get there, you figure it out on your own. In Mrs. Teske's class, that happened all the time.
 Mrs. Teske was my 7th and 8th grade teacher at St. John's Lutheran School in Buckley. My class only had about ten students, and she taught us almost every subject. I spent almost every school day with her for two years. My sister had her as a teacher, too, and my brother still goes there.
-My 7th and 8th grade teacher, Mrs. Teske, is one of the main reasons I was ready for high school.
+My 7th and 8th grade teacher, Mrs. Kata Teske, is one of the main reasons I was ready for high school.
 She was caring, she was dedicated to getting us ready, and both traits had a big impact on the student I am today.</a:t>
             </a:r>
             <a:endParaRPr lang="en-US" dirty="0"/>

</xml_diff>

<commit_message>
Tighten tribute speech to the rubric and add a 4th content slide
MP3 now ties each trait to its impact, the closure starts with a
thought about her, and Caring is split across two slides so there are
four main-point slides. Speaker notes are read from speech.md, and the
README has a requirement-by-requirement checklist.

Co-Authored-By: Claude Opus 5.5 <noreply@anthropic.com>
Claude-Session: https://claude.ai/code/session_01XxaKdzJdgg9PZDJGp43nnJ
</commit_message>
<xml_diff>
--- a/tribute-speech/Tribute_Speech_Mrs_Teske.pptx
+++ b/tribute-speech/Tribute_Speech_Mrs_Teske.pptx
@@ -10,9 +10,10 @@
     <p:sldId id="258" r:id="rId4"/>
     <p:sldId id="259" r:id="rId5"/>
     <p:sldId id="260" r:id="rId6"/>
+    <p:sldId id="261" r:id="rId7"/>
   </p:sldIdLst>
   <p:notesMasterIdLst>
-    <p:notesMasterId r:id="rId7"/>
+    <p:notesMasterId r:id="rId8"/>
   </p:notesMasterIdLst>
   <p:sldSz cx="9144000" cy="5143500"/>
   <p:notesSz cx="5143500" cy="9144000"/>
@@ -111,21 +112,22 @@
   <p:extLst>
     <p:ext uri="{521415D9-36F7-43E2-AB2F-B90AF26B5E84}">
       <p14:sectionLst xmlns:p14="http://schemas.microsoft.com/office/powerpoint/2010/main">
-        <p14:section name="Introduction" id="{3e46b482-0948-d77b-3f03-e87769bb9fa6}">
+        <p14:section name="Introduction" id="{71db05aa-3ad1-9773-4f00-7bb21b2aef9a}">
           <p14:sldIdLst>
             <p14:sldId id="256"/>
           </p14:sldIdLst>
         </p14:section>
-        <p14:section name="Body" id="{6414ccf3-af87-d3b4-455b-0279f1feed9c}">
+        <p14:section name="Body" id="{490a03fe-5afe-b036-2033-106ce06fbd62}">
           <p14:sldIdLst>
             <p14:sldId id="257"/>
             <p14:sldId id="258"/>
             <p14:sldId id="259"/>
+            <p14:sldId id="260"/>
           </p14:sldIdLst>
         </p14:section>
-        <p14:section name="Conclusion" id="{d261a4e3-e20f-db28-ac9e-b47a2cc8a31a}">
+        <p14:section name="Conclusion" id="{e90d7bcc-b57c-e4c9-0085-7dd8871f286e}">
           <p14:sldIdLst>
-            <p14:sldId id="260"/>
+            <p14:sldId id="261"/>
           </p14:sldIdLst>
         </p14:section>
       </p14:sectionLst>
@@ -534,7 +536,7 @@
               <a:rPr lang="en-US" dirty="0"/>
               <a:t>INTRO
 Imagine you are stuck on a homework problem. You walk up to the teacher's desk to ask for help. But the second you get there, you figure it out on your own. In Mrs. Teske's class, that happened all the time.
-Mrs. Teske was my 7th and 8th grade teacher at St. John's Lutheran School in Buckley. My class only had about ten students, and she taught us almost every subject. I spent almost every school day with her for two years. My sister had her as a teacher, too, and my brother still goes there.
+Mrs. Teske was my 7th and 8th grade teacher at St. John's Lutheran School in Buckley. My class only had about ten students, and she taught us almost every subject for two years. My sister had her as a teacher, too, and my brother still goes there.
 My 7th and 8th grade teacher, Mrs. Kata Teske, is one of the main reasons I was ready for high school.
 She was caring, she was dedicated to getting us ready, and both traits had a big impact on the student I am today.</a:t>
             </a:r>
@@ -624,9 +626,9 @@
           <a:p>
             <a:r>
               <a:rPr lang="en-US" dirty="0"/>
-              <a:t>MAIN POINT 1: CARING
-First, Mrs. Teske was caring. In 7th grade, I was the only boy in my class, but she treated me the same as everyone else, so it never felt weird. She could tell when our whole class was struggling, and she would slow down and explain it in a way that made sense. You could walk up to her desk at any time, and she would explain it until you got it. She also made class fun. Every day in December, she gave us a treat, and we had a party for every holiday. She told us stories about her family and her past students, and sometimes spelling tests turned into story time.
-TRANSITION: Mrs. Teske cared about us, but she also expected a lot from us.</a:t>
+              <a:t>MAIN POINT 1: CARING (part 1)
+First, Mrs. Teske was caring. In 7th grade, I was the only boy in my class, but she treated me the same as everyone else, so it never felt weird. She could tell when our whole class was struggling, and she would slow down and explain it in a way that made sense. You could walk up to her desk at any time, and she would explain it until you got it.
+[CLICK → SLIDE 3]</a:t>
             </a:r>
             <a:endParaRPr lang="en-US" dirty="0"/>
           </a:p>
@@ -714,9 +716,9 @@
           <a:p>
             <a:r>
               <a:rPr lang="en-US" dirty="0"/>
-              <a:t>MAIN POINT 2: DEDICATED
-Second, Mrs. Teske was dedicated to getting us ready for high school. She gave us quite a bit of homework, and there were no excuses for late work. Her tests were hard, but she offered extra credit because she wanted us to do well. She just wanted us to earn it. In her class, nobody really thought about slacking off. Working hard was just normal.
-TRANSITION: Her caring and her dedication did not just help me in middle school. They still help me today.</a:t>
+              <a:t>MAIN POINT 1: CARING (part 2)
+She also made class fun. Every day in December, she gave us a treat, and we had a party for every holiday. She told us stories about her family and her past students, and sometimes spelling tests turned into story time.
+TRANSITION: Mrs. Teske cared about us, but she also expected a lot from us.</a:t>
             </a:r>
             <a:endParaRPr lang="en-US" dirty="0"/>
           </a:p>
@@ -804,8 +806,9 @@
           <a:p>
             <a:r>
               <a:rPr lang="en-US" dirty="0"/>
-              <a:t>MAIN POINT 3: IMPACT ON ME
-Mrs. Teske helped make me the student I am today. It was not only her, but she was the teacher I spent almost every day with. When I got to high school, I was more prepared than a lot of other students. Now I am in advanced classes and in the top ten of my class. I am also more confident when something is hard, because she taught me I could figure it out if I kept working. Her caring made me feel like I could do it, and her dedication made sure I actually did.</a:t>
+              <a:t>MAIN POINT 2: DEDICATED
+Second, Mrs. Teske was dedicated to getting us ready for high school. She gave us quite a bit of homework, and there were no excuses for late work. Her tests were hard, but she offered extra credit because she wanted us to do well. She just wanted us to earn it. In her class, nobody really thought about slacking off. Working hard was just normal.
+TRANSITION: Her caring and her dedication still help me today.</a:t>
             </a:r>
             <a:endParaRPr lang="en-US" dirty="0"/>
           </a:p>
@@ -893,10 +896,8 @@
           <a:p>
             <a:r>
               <a:rPr lang="en-US" dirty="0"/>
-              <a:t>CONCLUSION
-Mrs. Teske's caring, her dedication, and her impact on me make her one of the most important teachers I have ever had.
-Think back to that walk up to her desk. I used to think it was funny that we figured it out as soon as we got there. Now I think she had already taught us how to work through it. We just needed to know she was there.
-The teachers who expect the most from you are usually the ones who care the most. If you have a teacher like that, do not wait to take it seriously. And if you get the chance, thank them. Mine was Mrs. Teske.</a:t>
+              <a:t>MAIN POINT 3: IMPACT ON ME
+Mrs. Teske helped make me the student I am today. It was not only her, but she was a big part of it. Because she was caring, I am more confident when something is hard. She always took the time to explain things, so I learned I could figure it out if I kept working. Because she was dedicated, I was ready for high school. I was more prepared than a lot of other students, and now I am in advanced classes and in the top ten of my class. Her caring made me feel like I could do it, and her dedication made sure I actually did.</a:t>
             </a:r>
             <a:endParaRPr lang="en-US" dirty="0"/>
           </a:p>
@@ -920,6 +921,97 @@
             <a:fld id="{F7021451-1387-4CA6-816F-3879F97B5CBC}" type="slidenum">
               <a:rPr lang="en-US"/>
               <a:t>5</a:t>
+            </a:fld>
+            <a:endParaRPr lang="en-US"/>
+          </a:p>
+        </p:txBody>
+      </p:sp>
+    </p:spTree>
+    <p:extLst>
+      <p:ext uri="{BB962C8B-B14F-4D97-AF65-F5344CB8AC3E}">
+        <p14:creationId xmlns:p14="http://schemas.microsoft.com/office/powerpoint/2010/main" val="1024086991"/>
+      </p:ext>
+    </p:extLst>
+  </p:cSld>
+  <p:clrMapOvr>
+    <a:masterClrMapping/>
+  </p:clrMapOvr>
+</p:notes>
+</file>
+
+<file path=ppt/notesSlides/notesSlide6.xml><?xml version="1.0" encoding="utf-8"?>
+<p:notes xmlns:a="http://schemas.openxmlformats.org/drawingml/2006/main" xmlns:r="http://schemas.openxmlformats.org/officeDocument/2006/relationships" xmlns:p="http://schemas.openxmlformats.org/presentationml/2006/main">
+  <p:cSld>
+    <p:spTree>
+      <p:nvGrpSpPr>
+        <p:cNvPr id="1" name=""/>
+        <p:cNvGrpSpPr/>
+        <p:nvPr/>
+      </p:nvGrpSpPr>
+      <p:grpSpPr>
+        <a:xfrm>
+          <a:off x="0" y="0"/>
+          <a:ext cx="0" cy="0"/>
+          <a:chOff x="0" y="0"/>
+          <a:chExt cx="0" cy="0"/>
+        </a:xfrm>
+      </p:grpSpPr>
+      <p:sp>
+        <p:nvSpPr>
+          <p:cNvPr id="2" name="Slide Image Placeholder 1"/>
+          <p:cNvSpPr>
+            <a:spLocks noGrp="1" noRot="1" noChangeAspect="1"/>
+          </p:cNvSpPr>
+          <p:nvPr>
+            <p:ph type="sldImg"/>
+          </p:nvPr>
+        </p:nvSpPr>
+        <p:spPr/>
+      </p:sp>
+      <p:sp>
+        <p:nvSpPr>
+          <p:cNvPr id="3" name="Notes Placeholder 2"/>
+          <p:cNvSpPr>
+            <a:spLocks noGrp="1"/>
+          </p:cNvSpPr>
+          <p:nvPr>
+            <p:ph type="body" idx="1"/>
+          </p:nvPr>
+        </p:nvSpPr>
+        <p:spPr/>
+        <p:txBody>
+          <a:bodyPr/>
+          <a:lstStyle/>
+          <a:p>
+            <a:r>
+              <a:rPr lang="en-US" dirty="0"/>
+              <a:t>CONCLUSION
+Mrs. Teske's caring, her dedication, and her impact on me make her one of the most important teachers I have ever had.
+Think back to that walk up to her desk. I used to think it was funny that we figured it out as soon as we got there. Now I think she had already taught us how to work through it. We just needed to know she was there.
+She showed me that the teachers who expect the most from you are usually the ones who care the most. If you have a teacher like that, do not wait to take it seriously. And if you get the chance, thank them. Mine was Mrs. Teske.</a:t>
+            </a:r>
+            <a:endParaRPr lang="en-US" dirty="0"/>
+          </a:p>
+        </p:txBody>
+      </p:sp>
+      <p:sp>
+        <p:nvSpPr>
+          <p:cNvPr id="4" name="Slide Number Placeholder 3"/>
+          <p:cNvSpPr>
+            <a:spLocks noGrp="1"/>
+          </p:cNvSpPr>
+          <p:nvPr>
+            <p:ph type="sldNum" sz="quarter" idx="10"/>
+          </p:nvPr>
+        </p:nvSpPr>
+        <p:spPr/>
+        <p:txBody>
+          <a:bodyPr/>
+          <a:lstStyle/>
+          <a:p>
+            <a:fld id="{F7021451-1387-4CA6-816F-3879F97B5CBC}" type="slidenum">
+              <a:rPr lang="en-US"/>
+              <a:t>6</a:t>
             </a:fld>
             <a:endParaRPr lang="en-US"/>
           </a:p>
@@ -1256,13 +1348,52 @@
           <p:cNvPr id="2" name="Text 0"/>
           <p:cNvSpPr/>
           <p:nvPr>
-            <p:ph idx="100" type="title" hasCustomPrompt="1"/>
+            <p:ph idx="100" type="body" hasCustomPrompt="1"/>
           </p:nvPr>
         </p:nvSpPr>
         <p:spPr>
           <a:xfrm>
-            <a:off x="640080" y="411480"/>
-            <a:ext cx="7863840" cy="777240"/>
+            <a:off x="640080" y="320040"/>
+            <a:ext cx="7863840" cy="320040"/>
+          </a:xfrm>
+          <a:prstGeom prst="rect">
+            <a:avLst/>
+          </a:prstGeom>
+          <a:noFill/>
+          <a:ln/>
+        </p:spPr>
+        <p:txBody>
+          <a:bodyPr wrap="square" rtlCol="0"/>
+          <a:lstStyle>
+            <a:lvl1pPr indent="0" marL="0">
+              <a:buNone/>
+              <a:defRPr lang="en-US" sz="1600" b="1" spc="400" kern="0" dirty="0">
+                <a:solidFill>
+                  <a:schemeClr val="accent1"/>
+                </a:solidFill>
+              </a:defRPr>
+            </a:lvl1pPr>
+          </a:lstStyle>
+          <a:p>
+            <a:pPr indent="0" marL="0">
+              <a:buNone/>
+            </a:pPr>
+            <a:endParaRPr lang="en-US" sz="1600" dirty="0"/>
+          </a:p>
+        </p:txBody>
+      </p:sp>
+      <p:sp>
+        <p:nvSpPr>
+          <p:cNvPr id="3" name="Text 0"/>
+          <p:cNvSpPr/>
+          <p:nvPr>
+            <p:ph idx="101" type="title" hasCustomPrompt="1"/>
+          </p:nvPr>
+        </p:nvSpPr>
+        <p:spPr>
+          <a:xfrm>
+            <a:off x="640080" y="658368"/>
+            <a:ext cx="7863840" cy="685800"/>
           </a:xfrm>
           <a:prstGeom prst="rect">
             <a:avLst/>
@@ -1372,6 +1503,116 @@
         <p:spPr>
           <a:xfrm>
             <a:off x="640080" y="2606040"/>
+            <a:ext cx="3108960" cy="731520"/>
+          </a:xfrm>
+          <a:prstGeom prst="rect">
+            <a:avLst/>
+          </a:prstGeom>
+          <a:noFill/>
+          <a:ln/>
+        </p:spPr>
+        <p:txBody>
+          <a:bodyPr wrap="square" rtlCol="0"/>
+          <a:lstStyle>
+            <a:lvl1pPr indent="0" marL="0">
+              <a:buNone/>
+              <a:defRPr lang="en-US" sz="1800" dirty="0">
+                <a:solidFill>
+                  <a:schemeClr val="accent1"/>
+                </a:solidFill>
+              </a:defRPr>
+            </a:lvl1pPr>
+          </a:lstStyle>
+          <a:p>
+            <a:pPr indent="0" marL="0">
+              <a:buNone/>
+            </a:pPr>
+            <a:endParaRPr lang="en-US" sz="1800" dirty="0"/>
+          </a:p>
+        </p:txBody>
+      </p:sp>
+    </p:spTree>
+  </p:cSld>
+  <p:clrMapOvr>
+    <a:masterClrMapping/>
+  </p:clrMapOvr>
+</p:sldLayout>
+</file>
+
+<file path=ppt/slideLayouts/slideLayout6.xml><?xml version="1.0" encoding="utf-8"?>
+<p:sldLayout xmlns:a="http://schemas.openxmlformats.org/drawingml/2006/main" xmlns:r="http://schemas.openxmlformats.org/officeDocument/2006/relationships" xmlns:p="http://schemas.openxmlformats.org/presentationml/2006/main" preserve="1">
+  <p:cSld name="SIDE_TITLE_RIGHT">
+    <p:bg>
+      <p:bgPr>
+        <a:solidFill>
+          <a:srgbClr val="26392F"/>
+        </a:solidFill>
+      </p:bgPr>
+    </p:bg>
+    <p:spTree>
+      <p:nvGrpSpPr>
+        <p:cNvPr id="1" name=""/>
+        <p:cNvGrpSpPr/>
+        <p:nvPr/>
+      </p:nvGrpSpPr>
+      <p:grpSpPr>
+        <a:xfrm>
+          <a:off x="0" y="0"/>
+          <a:ext cx="0" cy="0"/>
+          <a:chOff x="0" y="0"/>
+          <a:chExt cx="0" cy="0"/>
+        </a:xfrm>
+      </p:grpSpPr>
+      <p:sp>
+        <p:nvSpPr>
+          <p:cNvPr id="2" name="Text 0"/>
+          <p:cNvSpPr/>
+          <p:nvPr>
+            <p:ph idx="100" type="title" hasCustomPrompt="1"/>
+          </p:nvPr>
+        </p:nvSpPr>
+        <p:spPr>
+          <a:xfrm>
+            <a:off x="5394960" y="1097280"/>
+            <a:ext cx="3200400" cy="1371600"/>
+          </a:xfrm>
+          <a:prstGeom prst="rect">
+            <a:avLst/>
+          </a:prstGeom>
+          <a:noFill/>
+          <a:ln/>
+        </p:spPr>
+        <p:txBody>
+          <a:bodyPr wrap="square" rtlCol="0"/>
+          <a:lstStyle>
+            <a:lvl1pPr indent="0" marL="0">
+              <a:buNone/>
+              <a:defRPr lang="en-US" sz="3600" b="1" dirty="0">
+                <a:solidFill>
+                  <a:schemeClr val="bg1"/>
+                </a:solidFill>
+              </a:defRPr>
+            </a:lvl1pPr>
+          </a:lstStyle>
+          <a:p>
+            <a:pPr indent="0" marL="0">
+              <a:buNone/>
+            </a:pPr>
+            <a:endParaRPr lang="en-US" sz="3600" dirty="0"/>
+          </a:p>
+        </p:txBody>
+      </p:sp>
+      <p:sp>
+        <p:nvSpPr>
+          <p:cNvPr id="3" name="Text 0"/>
+          <p:cNvSpPr/>
+          <p:nvPr>
+            <p:ph idx="101" type="body" hasCustomPrompt="1"/>
+          </p:nvPr>
+        </p:nvSpPr>
+        <p:spPr>
+          <a:xfrm>
+            <a:off x="5394960" y="2606040"/>
             <a:ext cx="3108960" cy="731520"/>
           </a:xfrm>
           <a:prstGeom prst="rect">
@@ -1434,6 +1675,7 @@
     <p:sldLayoutId id="2147483651" r:id="rId3"/>
     <p:sldLayoutId id="2147483652" r:id="rId4"/>
     <p:sldLayoutId id="2147483653" r:id="rId5"/>
+    <p:sldLayoutId id="2147483654" r:id="rId6"/>
   </p:sldLayoutIdLst>
   <p:hf sldNum="0" hdr="0" ftr="0" dt="0"/>
   <p:txStyles>
@@ -2035,8 +2277,8 @@
         </p:nvSpPr>
         <p:spPr>
           <a:xfrm>
-            <a:off x="640080" y="411480"/>
-            <a:ext cx="7863840" cy="777240"/>
+            <a:off x="640080" y="1097280"/>
+            <a:ext cx="3291840" cy="1371600"/>
           </a:xfrm>
           <a:prstGeom prst="rect">
             <a:avLst/>
@@ -2045,34 +2287,72 @@
           <a:ln/>
         </p:spPr>
         <p:txBody>
-          <a:bodyPr wrap="square" lIns="0" tIns="0" rIns="0" bIns="0" rtlCol="0" anchor="ctr"/>
+          <a:bodyPr wrap="square" lIns="0" tIns="0" rIns="0" bIns="0" rtlCol="0" anchor="b"/>
           <a:lstStyle/>
           <a:p>
             <a:pPr indent="0" marL="0">
               <a:buNone/>
             </a:pPr>
             <a:r>
-              <a:rPr lang="en-US" sz="4000" b="1" dirty="0">
+              <a:rPr lang="en-US" sz="3600" b="1" dirty="0">
                 <a:solidFill>
                   <a:schemeClr val="bg1"/>
                 </a:solidFill>
               </a:rPr>
               <a:t>Caring</a:t>
             </a:r>
-            <a:endParaRPr lang="en-US" sz="4000" dirty="0"/>
-          </a:p>
-        </p:txBody>
-      </p:sp>
-      <p:sp>
-        <p:nvSpPr>
-          <p:cNvPr id="3" name="Class frame"/>
+            <a:endParaRPr lang="en-US" sz="3600" dirty="0"/>
+          </a:p>
+        </p:txBody>
+      </p:sp>
+      <p:sp>
+        <p:nvSpPr>
+          <p:cNvPr id="3" name="Text 0"/>
+          <p:cNvSpPr/>
+          <p:nvPr>
+            <p:ph idx="101" type="body" hasCustomPrompt="1"/>
+          </p:nvPr>
+        </p:nvSpPr>
+        <p:spPr>
+          <a:xfrm>
+            <a:off x="640080" y="2606040"/>
+            <a:ext cx="3108960" cy="731520"/>
+          </a:xfrm>
+          <a:prstGeom prst="rect">
+            <a:avLst/>
+          </a:prstGeom>
+          <a:noFill/>
+          <a:ln/>
+        </p:spPr>
+        <p:txBody>
+          <a:bodyPr wrap="square" lIns="0" tIns="0" rIns="0" bIns="0" rtlCol="0" anchor="t"/>
+          <a:lstStyle/>
+          <a:p>
+            <a:pPr indent="0" marL="0">
+              <a:buNone/>
+            </a:pPr>
+            <a:r>
+              <a:rPr lang="en-US" sz="1800" dirty="0">
+                <a:solidFill>
+                  <a:schemeClr val="accent1"/>
+                </a:solidFill>
+              </a:rPr>
+              <a:t>Always There to Help</a:t>
+            </a:r>
+            <a:endParaRPr lang="en-US" sz="1800" dirty="0"/>
+          </a:p>
+        </p:txBody>
+      </p:sp>
+      <p:sp>
+        <p:nvSpPr>
+          <p:cNvPr id="4" name="Teaching frame"/>
           <p:cNvSpPr/>
           <p:nvPr/>
         </p:nvSpPr>
         <p:spPr>
-          <a:xfrm rot="-180000">
-            <a:off x="754380" y="1773936"/>
-            <a:ext cx="2331720" cy="2487168"/>
+          <a:xfrm rot="120000">
+            <a:off x="4114800" y="790956"/>
+            <a:ext cx="4297680" cy="3630168"/>
           </a:xfrm>
           <a:prstGeom prst="rect">
             <a:avLst/>
@@ -2092,7 +2372,7 @@
       </p:sp>
       <p:pic>
         <p:nvPicPr>
-          <p:cNvPr id="4" name="Class photo" descr="Mrs. Teske with your class">    </p:cNvPr>
+          <p:cNvPr id="5" name="Teaching photo" descr="Mrs. Teske teaching, helping, or at her desk">    </p:cNvPr>
           <p:cNvPicPr>
             <a:picLocks noChangeAspect="1"/>
           </p:cNvPicPr>
@@ -2105,9 +2385,9 @@
           </a:stretch>
         </p:blipFill>
         <p:spPr>
-          <a:xfrm rot="-180000">
-            <a:off x="855015" y="1883902"/>
-            <a:ext cx="2112264" cy="1920240"/>
+          <a:xfrm rot="120000">
+            <a:off x="4230591" y="900790"/>
+            <a:ext cx="4078224" cy="3063240"/>
           </a:xfrm>
           <a:prstGeom prst="rect">
             <a:avLst/>
@@ -2116,14 +2396,14 @@
       </p:pic>
       <p:sp>
         <p:nvSpPr>
-          <p:cNvPr id="5" name="Class caption"/>
+          <p:cNvPr id="6" name="Teaching caption"/>
           <p:cNvSpPr txBox="1"/>
           <p:nvPr/>
         </p:nvSpPr>
         <p:spPr>
-          <a:xfrm rot="-180000">
-            <a:off x="917228" y="3802513"/>
-            <a:ext cx="2112264" cy="457200"/>
+          <a:xfrm rot="120000">
+            <a:off x="4169161" y="3962958"/>
+            <a:ext cx="4078224" cy="457200"/>
           </a:xfrm>
           <a:prstGeom prst="rect">
             <a:avLst/>
@@ -2147,187 +2427,7 @@
                 <a:ea typeface="Cambria" pitchFamily="34" charset="-122"/>
                 <a:cs typeface="Cambria" pitchFamily="34" charset="-120"/>
               </a:rPr>
-              <a:t>Our Class</a:t>
-            </a:r>
-            <a:endParaRPr lang="en-US" sz="1400" dirty="0"/>
-          </a:p>
-        </p:txBody>
-      </p:sp>
-      <p:sp>
-        <p:nvSpPr>
-          <p:cNvPr id="6" name="Parties frame"/>
-          <p:cNvSpPr/>
-          <p:nvPr/>
-        </p:nvSpPr>
-        <p:spPr>
-          <a:xfrm rot="120000">
-            <a:off x="3406140" y="1773936"/>
-            <a:ext cx="2331720" cy="2487168"/>
-          </a:xfrm>
-          <a:prstGeom prst="rect">
-            <a:avLst/>
-          </a:prstGeom>
-          <a:solidFill>
-            <a:schemeClr val="bg1"/>
-          </a:solidFill>
-          <a:ln/>
-          <a:effectLst>
-            <a:outerShdw sx="100000" sy="100000" kx="0" ky="0" algn="bl" rotWithShape="0" blurRad="101600" dist="38100" dir="5400000">
-              <a:srgbClr val="000000">
-                <a:alpha val="40000"/>
-              </a:srgbClr>
-            </a:outerShdw>
-          </a:effectLst>
-        </p:spPr>
-      </p:sp>
-      <p:pic>
-        <p:nvPicPr>
-          <p:cNvPr id="7" name="Parties photo" descr="A holiday party in her class">    </p:cNvPr>
-          <p:cNvPicPr>
-            <a:picLocks noChangeAspect="1"/>
-          </p:cNvPicPr>
-          <p:nvPr/>
-        </p:nvPicPr>
-        <p:blipFill>
-          <a:blip r:embed="rId2"/>
-          <a:stretch>
-            <a:fillRect/>
-          </a:stretch>
-        </p:blipFill>
-        <p:spPr>
-          <a:xfrm rot="120000">
-            <a:off x="3521931" y="1883770"/>
-            <a:ext cx="2112264" cy="1920240"/>
-          </a:xfrm>
-          <a:prstGeom prst="rect">
-            <a:avLst/>
-          </a:prstGeom>
-        </p:spPr>
-      </p:pic>
-      <p:sp>
-        <p:nvSpPr>
-          <p:cNvPr id="8" name="Parties caption"/>
-          <p:cNvSpPr txBox="1"/>
-          <p:nvPr/>
-        </p:nvSpPr>
-        <p:spPr>
-          <a:xfrm rot="120000">
-            <a:off x="3480446" y="3803286"/>
-            <a:ext cx="2112264" cy="457200"/>
-          </a:xfrm>
-          <a:prstGeom prst="rect">
-            <a:avLst/>
-          </a:prstGeom>
-          <a:noFill/>
-          <a:ln/>
-        </p:spPr>
-        <p:txBody>
-          <a:bodyPr wrap="square" lIns="0" tIns="0" rIns="0" bIns="0" rtlCol="0" anchor="ctr"/>
-          <a:lstStyle/>
-          <a:p>
-            <a:pPr algn="ctr" indent="0" marL="0">
-              <a:buNone/>
-            </a:pPr>
-            <a:r>
-              <a:rPr lang="en-US" sz="1400" i="1" dirty="0">
-                <a:solidFill>
-                  <a:schemeClr val="tx1"/>
-                </a:solidFill>
-                <a:latin typeface="Cambria" pitchFamily="34" charset="0"/>
-                <a:ea typeface="Cambria" pitchFamily="34" charset="-122"/>
-                <a:cs typeface="Cambria" pitchFamily="34" charset="-120"/>
-              </a:rPr>
-              <a:t>Holiday Parties</a:t>
-            </a:r>
-            <a:endParaRPr lang="en-US" sz="1400" dirty="0"/>
-          </a:p>
-        </p:txBody>
-      </p:sp>
-      <p:sp>
-        <p:nvSpPr>
-          <p:cNvPr id="9" name="Treats frame"/>
-          <p:cNvSpPr/>
-          <p:nvPr/>
-        </p:nvSpPr>
-        <p:spPr>
-          <a:xfrm rot="-120000">
-            <a:off x="6057900" y="1773936"/>
-            <a:ext cx="2331720" cy="2487168"/>
-          </a:xfrm>
-          <a:prstGeom prst="rect">
-            <a:avLst/>
-          </a:prstGeom>
-          <a:solidFill>
-            <a:schemeClr val="bg1"/>
-          </a:solidFill>
-          <a:ln/>
-          <a:effectLst>
-            <a:outerShdw sx="100000" sy="100000" kx="0" ky="0" algn="bl" rotWithShape="0" blurRad="101600" dist="38100" dir="5400000">
-              <a:srgbClr val="000000">
-                <a:alpha val="40000"/>
-              </a:srgbClr>
-            </a:outerShdw>
-          </a:effectLst>
-        </p:spPr>
-      </p:sp>
-      <p:pic>
-        <p:nvPicPr>
-          <p:cNvPr id="10" name="Treats photo" descr="December treats or her room at Christmas">    </p:cNvPr>
-          <p:cNvPicPr>
-            <a:picLocks noChangeAspect="1"/>
-          </p:cNvPicPr>
-          <p:nvPr/>
-        </p:nvPicPr>
-        <p:blipFill>
-          <a:blip r:embed="rId3"/>
-          <a:stretch>
-            <a:fillRect/>
-          </a:stretch>
-        </p:blipFill>
-        <p:spPr>
-          <a:xfrm rot="-120000">
-            <a:off x="6161565" y="1883770"/>
-            <a:ext cx="2112264" cy="1920240"/>
-          </a:xfrm>
-          <a:prstGeom prst="rect">
-            <a:avLst/>
-          </a:prstGeom>
-        </p:spPr>
-      </p:pic>
-      <p:sp>
-        <p:nvSpPr>
-          <p:cNvPr id="11" name="Treats caption"/>
-          <p:cNvSpPr txBox="1"/>
-          <p:nvPr/>
-        </p:nvSpPr>
-        <p:spPr>
-          <a:xfrm rot="-120000">
-            <a:off x="6203050" y="3803286"/>
-            <a:ext cx="2112264" cy="457200"/>
-          </a:xfrm>
-          <a:prstGeom prst="rect">
-            <a:avLst/>
-          </a:prstGeom>
-          <a:noFill/>
-          <a:ln/>
-        </p:spPr>
-        <p:txBody>
-          <a:bodyPr wrap="square" lIns="0" tIns="0" rIns="0" bIns="0" rtlCol="0" anchor="ctr"/>
-          <a:lstStyle/>
-          <a:p>
-            <a:pPr algn="ctr" indent="0" marL="0">
-              <a:buNone/>
-            </a:pPr>
-            <a:r>
-              <a:rPr lang="en-US" sz="1400" i="1" dirty="0">
-                <a:solidFill>
-                  <a:schemeClr val="tx1"/>
-                </a:solidFill>
-                <a:latin typeface="Cambria" pitchFamily="34" charset="0"/>
-                <a:ea typeface="Cambria" pitchFamily="34" charset="-122"/>
-                <a:cs typeface="Cambria" pitchFamily="34" charset="-120"/>
-              </a:rPr>
-              <a:t>December Treats</a:t>
+              <a:t>Mrs. Teske Teaching</a:t>
             </a:r>
             <a:endParaRPr lang="en-US" sz="1400" dirty="0"/>
           </a:p>
@@ -2363,13 +2463,13 @@
           <p:cNvPr id="2" name="Text 0"/>
           <p:cNvSpPr/>
           <p:nvPr>
-            <p:ph idx="100" type="title" hasCustomPrompt="1"/>
+            <p:ph idx="100" type="body" hasCustomPrompt="1"/>
           </p:nvPr>
         </p:nvSpPr>
         <p:spPr>
           <a:xfrm>
-            <a:off x="640080" y="1097280"/>
-            <a:ext cx="3291840" cy="1371600"/>
+            <a:off x="640080" y="320040"/>
+            <a:ext cx="7863840" cy="320040"/>
           </a:xfrm>
           <a:prstGeom prst="rect">
             <a:avLst/>
@@ -2385,65 +2485,65 @@
               <a:buNone/>
             </a:pPr>
             <a:r>
-              <a:rPr lang="en-US" sz="3600" b="1" dirty="0">
+              <a:rPr lang="en-US" sz="1600" b="1" spc="400" kern="0" dirty="0">
+                <a:solidFill>
+                  <a:schemeClr val="accent1"/>
+                </a:solidFill>
+              </a:rPr>
+              <a:t>MADE CLASS FUN</a:t>
+            </a:r>
+            <a:endParaRPr lang="en-US" sz="1600" dirty="0"/>
+          </a:p>
+        </p:txBody>
+      </p:sp>
+      <p:sp>
+        <p:nvSpPr>
+          <p:cNvPr id="3" name="Text 0"/>
+          <p:cNvSpPr/>
+          <p:nvPr>
+            <p:ph idx="101" type="title" hasCustomPrompt="1"/>
+          </p:nvPr>
+        </p:nvSpPr>
+        <p:spPr>
+          <a:xfrm>
+            <a:off x="640080" y="658368"/>
+            <a:ext cx="7863840" cy="685800"/>
+          </a:xfrm>
+          <a:prstGeom prst="rect">
+            <a:avLst/>
+          </a:prstGeom>
+          <a:noFill/>
+          <a:ln/>
+        </p:spPr>
+        <p:txBody>
+          <a:bodyPr wrap="square" lIns="0" tIns="0" rIns="0" bIns="0" rtlCol="0" anchor="t"/>
+          <a:lstStyle/>
+          <a:p>
+            <a:pPr indent="0" marL="0">
+              <a:buNone/>
+            </a:pPr>
+            <a:r>
+              <a:rPr lang="en-US" sz="4000" b="1" dirty="0">
                 <a:solidFill>
                   <a:schemeClr val="bg1"/>
                 </a:solidFill>
               </a:rPr>
-              <a:t>Dedicated</a:t>
+              <a:t>Caring</a:t>
             </a:r>
-            <a:endParaRPr lang="en-US" sz="3600" dirty="0"/>
-          </a:p>
-        </p:txBody>
-      </p:sp>
-      <p:sp>
-        <p:nvSpPr>
-          <p:cNvPr id="3" name="Text 0"/>
-          <p:cNvSpPr/>
-          <p:nvPr>
-            <p:ph idx="101" type="body" hasCustomPrompt="1"/>
-          </p:nvPr>
-        </p:nvSpPr>
-        <p:spPr>
-          <a:xfrm>
-            <a:off x="640080" y="2606040"/>
-            <a:ext cx="3108960" cy="731520"/>
-          </a:xfrm>
-          <a:prstGeom prst="rect">
-            <a:avLst/>
-          </a:prstGeom>
-          <a:noFill/>
-          <a:ln/>
-        </p:spPr>
-        <p:txBody>
-          <a:bodyPr wrap="square" lIns="0" tIns="0" rIns="0" bIns="0" rtlCol="0" anchor="t"/>
-          <a:lstStyle/>
-          <a:p>
-            <a:pPr indent="0" marL="0">
-              <a:buNone/>
-            </a:pPr>
-            <a:r>
-              <a:rPr lang="en-US" sz="1800" dirty="0">
-                <a:solidFill>
-                  <a:schemeClr val="accent1"/>
-                </a:solidFill>
-              </a:rPr>
-              <a:t>High Expectations</a:t>
-            </a:r>
-            <a:endParaRPr lang="en-US" sz="1800" dirty="0"/>
-          </a:p>
-        </p:txBody>
-      </p:sp>
-      <p:sp>
-        <p:nvSpPr>
-          <p:cNvPr id="4" name="Classroom frame"/>
+            <a:endParaRPr lang="en-US" sz="4000" dirty="0"/>
+          </a:p>
+        </p:txBody>
+      </p:sp>
+      <p:sp>
+        <p:nvSpPr>
+          <p:cNvPr id="4" name="Parties frame"/>
           <p:cNvSpPr/>
           <p:nvPr/>
         </p:nvSpPr>
         <p:spPr>
-          <a:xfrm rot="120000">
-            <a:off x="4114800" y="790956"/>
-            <a:ext cx="4297680" cy="3630168"/>
+          <a:xfrm rot="-180000">
+            <a:off x="754380" y="1911096"/>
+            <a:ext cx="2331720" cy="2487168"/>
           </a:xfrm>
           <a:prstGeom prst="rect">
             <a:avLst/>
@@ -2463,7 +2563,7 @@
       </p:sp>
       <p:pic>
         <p:nvPicPr>
-          <p:cNvPr id="5" name="Classroom photo" descr="Mrs. Teske teaching or at her desk">    </p:cNvPr>
+          <p:cNvPr id="5" name="Parties photo" descr="A holiday party in her class">    </p:cNvPr>
           <p:cNvPicPr>
             <a:picLocks noChangeAspect="1"/>
           </p:cNvPicPr>
@@ -2476,9 +2576,9 @@
           </a:stretch>
         </p:blipFill>
         <p:spPr>
-          <a:xfrm rot="120000">
-            <a:off x="4230591" y="900790"/>
-            <a:ext cx="4078224" cy="3063240"/>
+          <a:xfrm rot="-180000">
+            <a:off x="855015" y="2021062"/>
+            <a:ext cx="2112264" cy="1920240"/>
           </a:xfrm>
           <a:prstGeom prst="rect">
             <a:avLst/>
@@ -2487,14 +2587,14 @@
       </p:pic>
       <p:sp>
         <p:nvSpPr>
-          <p:cNvPr id="6" name="Classroom caption"/>
+          <p:cNvPr id="6" name="Parties caption"/>
           <p:cNvSpPr txBox="1"/>
           <p:nvPr/>
         </p:nvSpPr>
         <p:spPr>
-          <a:xfrm rot="120000">
-            <a:off x="4169161" y="3962958"/>
-            <a:ext cx="4078224" cy="457200"/>
+          <a:xfrm rot="-180000">
+            <a:off x="917228" y="3939673"/>
+            <a:ext cx="2112264" cy="457200"/>
           </a:xfrm>
           <a:prstGeom prst="rect">
             <a:avLst/>
@@ -2518,7 +2618,187 @@
                 <a:ea typeface="Cambria" pitchFamily="34" charset="-122"/>
                 <a:cs typeface="Cambria" pitchFamily="34" charset="-120"/>
               </a:rPr>
-              <a:t>Mrs. Teske's Classroom</a:t>
+              <a:t>Holiday Parties</a:t>
+            </a:r>
+            <a:endParaRPr lang="en-US" sz="1400" dirty="0"/>
+          </a:p>
+        </p:txBody>
+      </p:sp>
+      <p:sp>
+        <p:nvSpPr>
+          <p:cNvPr id="7" name="Treats frame"/>
+          <p:cNvSpPr/>
+          <p:nvPr/>
+        </p:nvSpPr>
+        <p:spPr>
+          <a:xfrm rot="120000">
+            <a:off x="3406140" y="1911096"/>
+            <a:ext cx="2331720" cy="2487168"/>
+          </a:xfrm>
+          <a:prstGeom prst="rect">
+            <a:avLst/>
+          </a:prstGeom>
+          <a:solidFill>
+            <a:schemeClr val="bg1"/>
+          </a:solidFill>
+          <a:ln/>
+          <a:effectLst>
+            <a:outerShdw sx="100000" sy="100000" kx="0" ky="0" algn="bl" rotWithShape="0" blurRad="101600" dist="38100" dir="5400000">
+              <a:srgbClr val="000000">
+                <a:alpha val="40000"/>
+              </a:srgbClr>
+            </a:outerShdw>
+          </a:effectLst>
+        </p:spPr>
+      </p:sp>
+      <p:pic>
+        <p:nvPicPr>
+          <p:cNvPr id="8" name="Treats photo" descr="December treats or her room at Christmas">    </p:cNvPr>
+          <p:cNvPicPr>
+            <a:picLocks noChangeAspect="1"/>
+          </p:cNvPicPr>
+          <p:nvPr/>
+        </p:nvPicPr>
+        <p:blipFill>
+          <a:blip r:embed="rId2"/>
+          <a:stretch>
+            <a:fillRect/>
+          </a:stretch>
+        </p:blipFill>
+        <p:spPr>
+          <a:xfrm rot="120000">
+            <a:off x="3521931" y="2020930"/>
+            <a:ext cx="2112264" cy="1920240"/>
+          </a:xfrm>
+          <a:prstGeom prst="rect">
+            <a:avLst/>
+          </a:prstGeom>
+        </p:spPr>
+      </p:pic>
+      <p:sp>
+        <p:nvSpPr>
+          <p:cNvPr id="9" name="Treats caption"/>
+          <p:cNvSpPr txBox="1"/>
+          <p:nvPr/>
+        </p:nvSpPr>
+        <p:spPr>
+          <a:xfrm rot="120000">
+            <a:off x="3480446" y="3940446"/>
+            <a:ext cx="2112264" cy="457200"/>
+          </a:xfrm>
+          <a:prstGeom prst="rect">
+            <a:avLst/>
+          </a:prstGeom>
+          <a:noFill/>
+          <a:ln/>
+        </p:spPr>
+        <p:txBody>
+          <a:bodyPr wrap="square" lIns="0" tIns="0" rIns="0" bIns="0" rtlCol="0" anchor="ctr"/>
+          <a:lstStyle/>
+          <a:p>
+            <a:pPr algn="ctr" indent="0" marL="0">
+              <a:buNone/>
+            </a:pPr>
+            <a:r>
+              <a:rPr lang="en-US" sz="1400" i="1" dirty="0">
+                <a:solidFill>
+                  <a:schemeClr val="tx1"/>
+                </a:solidFill>
+                <a:latin typeface="Cambria" pitchFamily="34" charset="0"/>
+                <a:ea typeface="Cambria" pitchFamily="34" charset="-122"/>
+                <a:cs typeface="Cambria" pitchFamily="34" charset="-120"/>
+              </a:rPr>
+              <a:t>December Treats</a:t>
+            </a:r>
+            <a:endParaRPr lang="en-US" sz="1400" dirty="0"/>
+          </a:p>
+        </p:txBody>
+      </p:sp>
+      <p:sp>
+        <p:nvSpPr>
+          <p:cNvPr id="10" name="Class frame"/>
+          <p:cNvSpPr/>
+          <p:nvPr/>
+        </p:nvSpPr>
+        <p:spPr>
+          <a:xfrm rot="-120000">
+            <a:off x="6057900" y="1911096"/>
+            <a:ext cx="2331720" cy="2487168"/>
+          </a:xfrm>
+          <a:prstGeom prst="rect">
+            <a:avLst/>
+          </a:prstGeom>
+          <a:solidFill>
+            <a:schemeClr val="bg1"/>
+          </a:solidFill>
+          <a:ln/>
+          <a:effectLst>
+            <a:outerShdw sx="100000" sy="100000" kx="0" ky="0" algn="bl" rotWithShape="0" blurRad="101600" dist="38100" dir="5400000">
+              <a:srgbClr val="000000">
+                <a:alpha val="40000"/>
+              </a:srgbClr>
+            </a:outerShdw>
+          </a:effectLst>
+        </p:spPr>
+      </p:sp>
+      <p:pic>
+        <p:nvPicPr>
+          <p:cNvPr id="11" name="Class photo" descr="Mrs. Teske with your class">    </p:cNvPr>
+          <p:cNvPicPr>
+            <a:picLocks noChangeAspect="1"/>
+          </p:cNvPicPr>
+          <p:nvPr/>
+        </p:nvPicPr>
+        <p:blipFill>
+          <a:blip r:embed="rId3"/>
+          <a:stretch>
+            <a:fillRect/>
+          </a:stretch>
+        </p:blipFill>
+        <p:spPr>
+          <a:xfrm rot="-120000">
+            <a:off x="6161565" y="2020930"/>
+            <a:ext cx="2112264" cy="1920240"/>
+          </a:xfrm>
+          <a:prstGeom prst="rect">
+            <a:avLst/>
+          </a:prstGeom>
+        </p:spPr>
+      </p:pic>
+      <p:sp>
+        <p:nvSpPr>
+          <p:cNvPr id="12" name="Class caption"/>
+          <p:cNvSpPr txBox="1"/>
+          <p:nvPr/>
+        </p:nvSpPr>
+        <p:spPr>
+          <a:xfrm rot="-120000">
+            <a:off x="6203050" y="3940446"/>
+            <a:ext cx="2112264" cy="457200"/>
+          </a:xfrm>
+          <a:prstGeom prst="rect">
+            <a:avLst/>
+          </a:prstGeom>
+          <a:noFill/>
+          <a:ln/>
+        </p:spPr>
+        <p:txBody>
+          <a:bodyPr wrap="square" lIns="0" tIns="0" rIns="0" bIns="0" rtlCol="0" anchor="ctr"/>
+          <a:lstStyle/>
+          <a:p>
+            <a:pPr algn="ctr" indent="0" marL="0">
+              <a:buNone/>
+            </a:pPr>
+            <a:r>
+              <a:rPr lang="en-US" sz="1400" i="1" dirty="0">
+                <a:solidFill>
+                  <a:schemeClr val="tx1"/>
+                </a:solidFill>
+                <a:latin typeface="Cambria" pitchFamily="34" charset="0"/>
+                <a:ea typeface="Cambria" pitchFamily="34" charset="-122"/>
+                <a:cs typeface="Cambria" pitchFamily="34" charset="-120"/>
+              </a:rPr>
+              <a:t>Our Class</a:t>
             </a:r>
             <a:endParaRPr lang="en-US" sz="1400" dirty="0"/>
           </a:p>
@@ -2559,6 +2839,197 @@
         </p:nvSpPr>
         <p:spPr>
           <a:xfrm>
+            <a:off x="5394960" y="1097280"/>
+            <a:ext cx="3200400" cy="1371600"/>
+          </a:xfrm>
+          <a:prstGeom prst="rect">
+            <a:avLst/>
+          </a:prstGeom>
+          <a:noFill/>
+          <a:ln/>
+        </p:spPr>
+        <p:txBody>
+          <a:bodyPr wrap="square" lIns="0" tIns="0" rIns="0" bIns="0" rtlCol="0" anchor="b"/>
+          <a:lstStyle/>
+          <a:p>
+            <a:pPr indent="0" marL="0">
+              <a:buNone/>
+            </a:pPr>
+            <a:r>
+              <a:rPr lang="en-US" sz="3600" b="1" dirty="0">
+                <a:solidFill>
+                  <a:schemeClr val="bg1"/>
+                </a:solidFill>
+              </a:rPr>
+              <a:t>Dedicated</a:t>
+            </a:r>
+            <a:endParaRPr lang="en-US" sz="3600" dirty="0"/>
+          </a:p>
+        </p:txBody>
+      </p:sp>
+      <p:sp>
+        <p:nvSpPr>
+          <p:cNvPr id="3" name="Text 0"/>
+          <p:cNvSpPr/>
+          <p:nvPr>
+            <p:ph idx="101" type="body" hasCustomPrompt="1"/>
+          </p:nvPr>
+        </p:nvSpPr>
+        <p:spPr>
+          <a:xfrm>
+            <a:off x="5394960" y="2606040"/>
+            <a:ext cx="3108960" cy="731520"/>
+          </a:xfrm>
+          <a:prstGeom prst="rect">
+            <a:avLst/>
+          </a:prstGeom>
+          <a:noFill/>
+          <a:ln/>
+        </p:spPr>
+        <p:txBody>
+          <a:bodyPr wrap="square" lIns="0" tIns="0" rIns="0" bIns="0" rtlCol="0" anchor="t"/>
+          <a:lstStyle/>
+          <a:p>
+            <a:pPr indent="0" marL="0">
+              <a:buNone/>
+            </a:pPr>
+            <a:r>
+              <a:rPr lang="en-US" sz="1800" dirty="0">
+                <a:solidFill>
+                  <a:schemeClr val="accent1"/>
+                </a:solidFill>
+              </a:rPr>
+              <a:t>High Expectations</a:t>
+            </a:r>
+            <a:endParaRPr lang="en-US" sz="1800" dirty="0"/>
+          </a:p>
+        </p:txBody>
+      </p:sp>
+      <p:sp>
+        <p:nvSpPr>
+          <p:cNvPr id="4" name="Classroom frame"/>
+          <p:cNvSpPr/>
+          <p:nvPr/>
+        </p:nvSpPr>
+        <p:spPr>
+          <a:xfrm rot="-120000">
+            <a:off x="731520" y="790956"/>
+            <a:ext cx="4297680" cy="3630168"/>
+          </a:xfrm>
+          <a:prstGeom prst="rect">
+            <a:avLst/>
+          </a:prstGeom>
+          <a:solidFill>
+            <a:schemeClr val="bg1"/>
+          </a:solidFill>
+          <a:ln/>
+          <a:effectLst>
+            <a:outerShdw sx="100000" sy="100000" kx="0" ky="0" algn="bl" rotWithShape="0" blurRad="101600" dist="38100" dir="5400000">
+              <a:srgbClr val="000000">
+                <a:alpha val="40000"/>
+              </a:srgbClr>
+            </a:outerShdw>
+          </a:effectLst>
+        </p:spPr>
+      </p:sp>
+      <p:pic>
+        <p:nvPicPr>
+          <p:cNvPr id="5" name="Classroom photo" descr="Her classroom (you could take a new photo of it)">    </p:cNvPr>
+          <p:cNvPicPr>
+            <a:picLocks noChangeAspect="1"/>
+          </p:cNvPicPr>
+          <p:nvPr/>
+        </p:nvPicPr>
+        <p:blipFill>
+          <a:blip r:embed="rId1"/>
+          <a:stretch>
+            <a:fillRect/>
+          </a:stretch>
+        </p:blipFill>
+        <p:spPr>
+          <a:xfrm rot="-120000">
+            <a:off x="835185" y="900790"/>
+            <a:ext cx="4078224" cy="3063240"/>
+          </a:xfrm>
+          <a:prstGeom prst="rect">
+            <a:avLst/>
+          </a:prstGeom>
+        </p:spPr>
+      </p:pic>
+      <p:sp>
+        <p:nvSpPr>
+          <p:cNvPr id="6" name="Classroom caption"/>
+          <p:cNvSpPr txBox="1"/>
+          <p:nvPr/>
+        </p:nvSpPr>
+        <p:spPr>
+          <a:xfrm rot="-120000">
+            <a:off x="896615" y="3962958"/>
+            <a:ext cx="4078224" cy="457200"/>
+          </a:xfrm>
+          <a:prstGeom prst="rect">
+            <a:avLst/>
+          </a:prstGeom>
+          <a:noFill/>
+          <a:ln/>
+        </p:spPr>
+        <p:txBody>
+          <a:bodyPr wrap="square" lIns="0" tIns="0" rIns="0" bIns="0" rtlCol="0" anchor="ctr"/>
+          <a:lstStyle/>
+          <a:p>
+            <a:pPr algn="ctr" indent="0" marL="0">
+              <a:buNone/>
+            </a:pPr>
+            <a:r>
+              <a:rPr lang="en-US" sz="1400" i="1" dirty="0">
+                <a:solidFill>
+                  <a:schemeClr val="tx1"/>
+                </a:solidFill>
+                <a:latin typeface="Cambria" pitchFamily="34" charset="0"/>
+                <a:ea typeface="Cambria" pitchFamily="34" charset="-122"/>
+                <a:cs typeface="Cambria" pitchFamily="34" charset="-120"/>
+              </a:rPr>
+              <a:t>Mrs. Teske's Classroom</a:t>
+            </a:r>
+            <a:endParaRPr lang="en-US" sz="1400" dirty="0"/>
+          </a:p>
+        </p:txBody>
+      </p:sp>
+    </p:spTree>
+  </p:cSld>
+  <p:clrMapOvr>
+    <a:masterClrMapping/>
+  </p:clrMapOvr>
+</p:sld>
+</file>
+
+<file path=ppt/slides/slide5.xml><?xml version="1.0" encoding="utf-8"?>
+<p:sld xmlns:a="http://schemas.openxmlformats.org/drawingml/2006/main" xmlns:r="http://schemas.openxmlformats.org/officeDocument/2006/relationships" xmlns:p="http://schemas.openxmlformats.org/presentationml/2006/main">
+  <p:cSld name="Slide 5">
+    <p:spTree>
+      <p:nvGrpSpPr>
+        <p:cNvPr id="1" name=""/>
+        <p:cNvGrpSpPr/>
+        <p:nvPr/>
+      </p:nvGrpSpPr>
+      <p:grpSpPr>
+        <a:xfrm>
+          <a:off x="0" y="0"/>
+          <a:ext cx="0" cy="0"/>
+          <a:chOff x="0" y="0"/>
+          <a:chExt cx="0" cy="0"/>
+        </a:xfrm>
+      </p:grpSpPr>
+      <p:sp>
+        <p:nvSpPr>
+          <p:cNvPr id="2" name="Text 0"/>
+          <p:cNvSpPr/>
+          <p:nvPr>
+            <p:ph idx="100" type="title" hasCustomPrompt="1"/>
+          </p:nvPr>
+        </p:nvSpPr>
+        <p:spPr>
+          <a:xfrm>
             <a:off x="640080" y="1097280"/>
             <a:ext cx="3291840" cy="1371600"/>
           </a:xfrm>
@@ -2813,9 +3284,9 @@
 </p:sld>
 </file>
 
-<file path=ppt/slides/slide5.xml><?xml version="1.0" encoding="utf-8"?>
+<file path=ppt/slides/slide6.xml><?xml version="1.0" encoding="utf-8"?>
 <p:sld xmlns:a="http://schemas.openxmlformats.org/drawingml/2006/main" xmlns:r="http://schemas.openxmlformats.org/officeDocument/2006/relationships" xmlns:p="http://schemas.openxmlformats.org/presentationml/2006/main">
-  <p:cSld name="Slide 5">
+  <p:cSld name="Slide 6">
     <p:spTree>
       <p:nvGrpSpPr>
         <p:cNvPr id="1" name=""/>

</xml_diff>

<commit_message>
Fit the tribute slides to the photos that were found
Our Class moves to the Always There to Help slide, the fun and
dedicated slides use free online photos (credited in the notes), titles
are left-aligned for Google Slides, and the builder can fill the
polaroids from a local photos folder. The photo-filled deck stays out
of this public repo.

Co-Authored-By: Claude Opus 5.5 <noreply@anthropic.com>
Claude-Session: https://claude.ai/code/session_01XxaKdzJdgg9PZDJGp43nnJ
</commit_message>
<xml_diff>
--- a/tribute-speech/Tribute_Speech_Mrs_Teske.pptx
+++ b/tribute-speech/Tribute_Speech_Mrs_Teske.pptx
@@ -112,12 +112,12 @@
   <p:extLst>
     <p:ext uri="{521415D9-36F7-43E2-AB2F-B90AF26B5E84}">
       <p14:sectionLst xmlns:p14="http://schemas.microsoft.com/office/powerpoint/2010/main">
-        <p14:section name="Introduction" id="{71db05aa-3ad1-9773-4f00-7bb21b2aef9a}">
+        <p14:section name="Introduction" id="{4275f228-4ea9-50d4-9c02-1ff1dde0f13a}">
           <p14:sldIdLst>
             <p14:sldId id="256"/>
           </p14:sldIdLst>
         </p14:section>
-        <p14:section name="Body" id="{490a03fe-5afe-b036-2033-106ce06fbd62}">
+        <p14:section name="Body" id="{cfe2fcc6-a71e-4fc1-4465-c9ae59b52d11}">
           <p14:sldIdLst>
             <p14:sldId id="257"/>
             <p14:sldId id="258"/>
@@ -125,7 +125,7 @@
             <p14:sldId id="260"/>
           </p14:sldIdLst>
         </p14:section>
-        <p14:section name="Conclusion" id="{e90d7bcc-b57c-e4c9-0085-7dd8871f286e}">
+        <p14:section name="Conclusion" id="{ca5b5e8b-6659-b67d-a8ce-bfc9dd34a0d8}">
           <p14:sldIdLst>
             <p14:sldId id="261"/>
           </p14:sldIdLst>
@@ -718,7 +718,8 @@
               <a:rPr lang="en-US" dirty="0"/>
               <a:t>MAIN POINT 1: CARING (part 2)
 She also made class fun. Every day in December, she gave us a treat, and we had a party for every holiday. She told us stories about her family and her past students, and sometimes spelling tests turned into story time.
-TRANSITION: Mrs. Teske cared about us, but she also expected a lot from us.</a:t>
+TRANSITION: Mrs. Teske cared about us, but she also expected a lot from us.
+Photo credits (Wikimedia Commons): "Colorful balloons 07" by Ibrahim Husain Meraj, CC BY-SA 4.0. "Seven sorts of cookies red" by WhatamIdoing, CC BY-SA 4.0.</a:t>
             </a:r>
             <a:endParaRPr lang="en-US" dirty="0"/>
           </a:p>
@@ -808,7 +809,8 @@
               <a:rPr lang="en-US" dirty="0"/>
               <a:t>MAIN POINT 2: DEDICATED
 Second, Mrs. Teske was dedicated to getting us ready for high school. She gave us quite a bit of homework, and there were no excuses for late work. Her tests were hard, but she offered extra credit because she wanted us to do well. She just wanted us to earn it. In her class, nobody really thought about slacking off. Working hard was just normal.
-TRANSITION: Her caring and her dedication still help me today.</a:t>
+TRANSITION: Her caring and her dedication still help me today.
+Photo credit (Wikimedia Commons): "Pencil shavings on a notebook" by Angelina Litvin, CC0.</a:t>
             </a:r>
             <a:endParaRPr lang="en-US" dirty="0"/>
           </a:p>
@@ -1145,7 +1147,7 @@
         <p:txBody>
           <a:bodyPr wrap="square" rtlCol="0"/>
           <a:lstStyle>
-            <a:lvl1pPr indent="0" marL="0">
+            <a:lvl1pPr algn="l" indent="0" marL="0">
               <a:buNone/>
               <a:defRPr lang="en-US" sz="4600" b="1" dirty="0">
                 <a:solidFill>
@@ -1155,7 +1157,7 @@
             </a:lvl1pPr>
           </a:lstStyle>
           <a:p>
-            <a:pPr indent="0" marL="0">
+            <a:pPr algn="l" indent="0" marL="0">
               <a:buNone/>
             </a:pPr>
             <a:endParaRPr lang="en-US" sz="4600" dirty="0"/>
@@ -1294,7 +1296,7 @@
         <p:txBody>
           <a:bodyPr wrap="square" rtlCol="0"/>
           <a:lstStyle>
-            <a:lvl1pPr indent="0" marL="0">
+            <a:lvl1pPr algn="l" indent="0" marL="0">
               <a:buNone/>
               <a:defRPr lang="en-US" sz="4400" b="1" dirty="0">
                 <a:solidFill>
@@ -1304,7 +1306,7 @@
             </a:lvl1pPr>
           </a:lstStyle>
           <a:p>
-            <a:pPr indent="0" marL="0">
+            <a:pPr algn="l" indent="0" marL="0">
               <a:buNone/>
             </a:pPr>
             <a:endParaRPr lang="en-US" sz="4400" dirty="0"/>
@@ -1404,7 +1406,7 @@
         <p:txBody>
           <a:bodyPr wrap="square" rtlCol="0"/>
           <a:lstStyle>
-            <a:lvl1pPr indent="0" marL="0">
+            <a:lvl1pPr algn="l" indent="0" marL="0">
               <a:buNone/>
               <a:defRPr lang="en-US" sz="4000" b="1" dirty="0">
                 <a:solidFill>
@@ -1414,7 +1416,7 @@
             </a:lvl1pPr>
           </a:lstStyle>
           <a:p>
-            <a:pPr indent="0" marL="0">
+            <a:pPr algn="l" indent="0" marL="0">
               <a:buNone/>
             </a:pPr>
             <a:endParaRPr lang="en-US" sz="4000" dirty="0"/>
@@ -1475,7 +1477,7 @@
         <p:txBody>
           <a:bodyPr wrap="square" rtlCol="0"/>
           <a:lstStyle>
-            <a:lvl1pPr indent="0" marL="0">
+            <a:lvl1pPr algn="l" indent="0" marL="0">
               <a:buNone/>
               <a:defRPr lang="en-US" sz="3600" b="1" dirty="0">
                 <a:solidFill>
@@ -1485,7 +1487,7 @@
             </a:lvl1pPr>
           </a:lstStyle>
           <a:p>
-            <a:pPr indent="0" marL="0">
+            <a:pPr algn="l" indent="0" marL="0">
               <a:buNone/>
             </a:pPr>
             <a:endParaRPr lang="en-US" sz="3600" dirty="0"/>
@@ -1585,7 +1587,7 @@
         <p:txBody>
           <a:bodyPr wrap="square" rtlCol="0"/>
           <a:lstStyle>
-            <a:lvl1pPr indent="0" marL="0">
+            <a:lvl1pPr algn="l" indent="0" marL="0">
               <a:buNone/>
               <a:defRPr lang="en-US" sz="3600" b="1" dirty="0">
                 <a:solidFill>
@@ -1595,7 +1597,7 @@
             </a:lvl1pPr>
           </a:lstStyle>
           <a:p>
-            <a:pPr indent="0" marL="0">
+            <a:pPr algn="l" indent="0" marL="0">
               <a:buNone/>
             </a:pPr>
             <a:endParaRPr lang="en-US" sz="3600" dirty="0"/>
@@ -2009,7 +2011,7 @@
           <a:bodyPr wrap="square" lIns="0" tIns="0" rIns="0" bIns="0" rtlCol="0" anchor="t"/>
           <a:lstStyle/>
           <a:p>
-            <a:pPr indent="0" marL="0">
+            <a:pPr algn="l" indent="0" marL="0">
               <a:buNone/>
             </a:pPr>
             <a:r>
@@ -2070,7 +2072,7 @@
         </p:nvSpPr>
         <p:spPr>
           <a:xfrm rot="-180000">
-            <a:off x="4617720" y="1110996"/>
+            <a:off x="4480560" y="1110996"/>
             <a:ext cx="2103120" cy="2807208"/>
           </a:xfrm>
           <a:prstGeom prst="rect">
@@ -2105,7 +2107,7 @@
         </p:blipFill>
         <p:spPr>
           <a:xfrm rot="-180000">
-            <a:off x="4718355" y="1220962"/>
+            <a:off x="4581195" y="1220962"/>
             <a:ext cx="1883664" cy="2240280"/>
           </a:xfrm>
           <a:prstGeom prst="rect">
@@ -2121,7 +2123,7 @@
         </p:nvSpPr>
         <p:spPr>
           <a:xfrm rot="-180000">
-            <a:off x="4788943" y="3459394"/>
+            <a:off x="4651783" y="3459394"/>
             <a:ext cx="1883664" cy="457200"/>
           </a:xfrm>
           <a:prstGeom prst="rect">
@@ -2160,8 +2162,8 @@
         </p:nvSpPr>
         <p:spPr>
           <a:xfrm rot="240000">
-            <a:off x="6675120" y="2025396"/>
-            <a:ext cx="2011680" cy="1984248"/>
+            <a:off x="6537960" y="2093976"/>
+            <a:ext cx="2103120" cy="1847088"/>
           </a:xfrm>
           <a:prstGeom prst="rect">
             <a:avLst/>
@@ -2195,8 +2197,8 @@
         </p:blipFill>
         <p:spPr>
           <a:xfrm rot="240000">
-            <a:off x="6796967" y="2135547"/>
-            <a:ext cx="1792224" cy="1417320"/>
+            <a:off x="6659807" y="2204127"/>
+            <a:ext cx="1883664" cy="1280160"/>
           </a:xfrm>
           <a:prstGeom prst="rect">
             <a:avLst/>
@@ -2211,8 +2213,8 @@
         </p:nvSpPr>
         <p:spPr>
           <a:xfrm rot="240000">
-            <a:off x="6731587" y="3550584"/>
-            <a:ext cx="1792224" cy="457200"/>
+            <a:off x="6599211" y="3482171"/>
+            <a:ext cx="1883664" cy="457200"/>
           </a:xfrm>
           <a:prstGeom prst="rect">
             <a:avLst/>
@@ -2228,7 +2230,7 @@
               <a:buNone/>
             </a:pPr>
             <a:r>
-              <a:rPr lang="en-US" sz="1400" i="1" dirty="0">
+              <a:rPr lang="en-US" sz="1100" i="1" dirty="0">
                 <a:solidFill>
                   <a:schemeClr val="tx1"/>
                 </a:solidFill>
@@ -2236,9 +2238,9 @@
                 <a:ea typeface="Cambria" pitchFamily="34" charset="-122"/>
                 <a:cs typeface="Cambria" pitchFamily="34" charset="-120"/>
               </a:rPr>
-              <a:t>St. John's Lutheran</a:t>
+              <a:t>St. John's Lutheran School</a:t>
             </a:r>
-            <a:endParaRPr lang="en-US" sz="1400" dirty="0"/>
+            <a:endParaRPr lang="en-US" sz="1100" dirty="0"/>
           </a:p>
         </p:txBody>
       </p:sp>
@@ -2290,7 +2292,7 @@
           <a:bodyPr wrap="square" lIns="0" tIns="0" rIns="0" bIns="0" rtlCol="0" anchor="b"/>
           <a:lstStyle/>
           <a:p>
-            <a:pPr indent="0" marL="0">
+            <a:pPr algn="l" indent="0" marL="0">
               <a:buNone/>
             </a:pPr>
             <a:r>
@@ -2345,7 +2347,7 @@
       </p:sp>
       <p:sp>
         <p:nvSpPr>
-          <p:cNvPr id="4" name="Teaching frame"/>
+          <p:cNvPr id="4" name="Class frame"/>
           <p:cNvSpPr/>
           <p:nvPr/>
         </p:nvSpPr>
@@ -2372,7 +2374,7 @@
       </p:sp>
       <p:pic>
         <p:nvPicPr>
-          <p:cNvPr id="5" name="Teaching photo" descr="Mrs. Teske teaching, helping, or at her desk">    </p:cNvPr>
+          <p:cNvPr id="5" name="Class photo" descr="Mrs. Teske with your class">    </p:cNvPr>
           <p:cNvPicPr>
             <a:picLocks noChangeAspect="1"/>
           </p:cNvPicPr>
@@ -2396,7 +2398,7 @@
       </p:pic>
       <p:sp>
         <p:nvSpPr>
-          <p:cNvPr id="6" name="Teaching caption"/>
+          <p:cNvPr id="6" name="Class caption"/>
           <p:cNvSpPr txBox="1"/>
           <p:nvPr/>
         </p:nvSpPr>
@@ -2427,7 +2429,7 @@
                 <a:ea typeface="Cambria" pitchFamily="34" charset="-122"/>
                 <a:cs typeface="Cambria" pitchFamily="34" charset="-120"/>
               </a:rPr>
-              <a:t>Mrs. Teske Teaching</a:t>
+              <a:t>Our Class</a:t>
             </a:r>
             <a:endParaRPr lang="en-US" sz="1400" dirty="0"/>
           </a:p>
@@ -2519,7 +2521,7 @@
           <a:bodyPr wrap="square" lIns="0" tIns="0" rIns="0" bIns="0" rtlCol="0" anchor="t"/>
           <a:lstStyle/>
           <a:p>
-            <a:pPr indent="0" marL="0">
+            <a:pPr algn="l" indent="0" marL="0">
               <a:buNone/>
             </a:pPr>
             <a:r>
@@ -2542,8 +2544,8 @@
         </p:nvSpPr>
         <p:spPr>
           <a:xfrm rot="-180000">
-            <a:off x="754380" y="1911096"/>
-            <a:ext cx="2331720" cy="2487168"/>
+            <a:off x="1280160" y="1705356"/>
+            <a:ext cx="3017520" cy="2898648"/>
           </a:xfrm>
           <a:prstGeom prst="rect">
             <a:avLst/>
@@ -2563,7 +2565,7 @@
       </p:sp>
       <p:pic>
         <p:nvPicPr>
-          <p:cNvPr id="5" name="Parties photo" descr="A holiday party in her class">    </p:cNvPr>
+          <p:cNvPr id="5" name="Parties photo" descr="Balloons or a holiday party">    </p:cNvPr>
           <p:cNvPicPr>
             <a:picLocks noChangeAspect="1"/>
           </p:cNvPicPr>
@@ -2577,8 +2579,8 @@
         </p:blipFill>
         <p:spPr>
           <a:xfrm rot="-180000">
-            <a:off x="855015" y="2021062"/>
-            <a:ext cx="2112264" cy="1920240"/>
+            <a:off x="1380795" y="1815322"/>
+            <a:ext cx="2798064" cy="2331720"/>
           </a:xfrm>
           <a:prstGeom prst="rect">
             <a:avLst/>
@@ -2593,8 +2595,8 @@
         </p:nvSpPr>
         <p:spPr>
           <a:xfrm rot="-180000">
-            <a:off x="917228" y="3939673"/>
-            <a:ext cx="2112264" cy="457200"/>
+            <a:off x="1453776" y="4145131"/>
+            <a:ext cx="2798064" cy="457200"/>
           </a:xfrm>
           <a:prstGeom prst="rect">
             <a:avLst/>
@@ -2632,8 +2634,8 @@
         </p:nvSpPr>
         <p:spPr>
           <a:xfrm rot="120000">
-            <a:off x="3406140" y="1911096"/>
-            <a:ext cx="2331720" cy="2487168"/>
+            <a:off x="4846320" y="1705356"/>
+            <a:ext cx="3017520" cy="2898648"/>
           </a:xfrm>
           <a:prstGeom prst="rect">
             <a:avLst/>
@@ -2653,7 +2655,7 @@
       </p:sp>
       <p:pic>
         <p:nvPicPr>
-          <p:cNvPr id="8" name="Treats photo" descr="December treats or her room at Christmas">    </p:cNvPr>
+          <p:cNvPr id="8" name="Treats photo" descr="Christmas cookies or treats">    </p:cNvPr>
           <p:cNvPicPr>
             <a:picLocks noChangeAspect="1"/>
           </p:cNvPicPr>
@@ -2667,8 +2669,8 @@
         </p:blipFill>
         <p:spPr>
           <a:xfrm rot="120000">
-            <a:off x="3521931" y="2020930"/>
-            <a:ext cx="2112264" cy="1920240"/>
+            <a:off x="4962111" y="1815190"/>
+            <a:ext cx="2798064" cy="2331720"/>
           </a:xfrm>
           <a:prstGeom prst="rect">
             <a:avLst/>
@@ -2683,8 +2685,8 @@
         </p:nvSpPr>
         <p:spPr>
           <a:xfrm rot="120000">
-            <a:off x="3480446" y="3940446"/>
-            <a:ext cx="2112264" cy="457200"/>
+            <a:off x="4913445" y="4146060"/>
+            <a:ext cx="2798064" cy="457200"/>
           </a:xfrm>
           <a:prstGeom prst="rect">
             <a:avLst/>
@@ -2709,96 +2711,6 @@
                 <a:cs typeface="Cambria" pitchFamily="34" charset="-120"/>
               </a:rPr>
               <a:t>December Treats</a:t>
-            </a:r>
-            <a:endParaRPr lang="en-US" sz="1400" dirty="0"/>
-          </a:p>
-        </p:txBody>
-      </p:sp>
-      <p:sp>
-        <p:nvSpPr>
-          <p:cNvPr id="10" name="Class frame"/>
-          <p:cNvSpPr/>
-          <p:nvPr/>
-        </p:nvSpPr>
-        <p:spPr>
-          <a:xfrm rot="-120000">
-            <a:off x="6057900" y="1911096"/>
-            <a:ext cx="2331720" cy="2487168"/>
-          </a:xfrm>
-          <a:prstGeom prst="rect">
-            <a:avLst/>
-          </a:prstGeom>
-          <a:solidFill>
-            <a:schemeClr val="bg1"/>
-          </a:solidFill>
-          <a:ln/>
-          <a:effectLst>
-            <a:outerShdw sx="100000" sy="100000" kx="0" ky="0" algn="bl" rotWithShape="0" blurRad="101600" dist="38100" dir="5400000">
-              <a:srgbClr val="000000">
-                <a:alpha val="40000"/>
-              </a:srgbClr>
-            </a:outerShdw>
-          </a:effectLst>
-        </p:spPr>
-      </p:sp>
-      <p:pic>
-        <p:nvPicPr>
-          <p:cNvPr id="11" name="Class photo" descr="Mrs. Teske with your class">    </p:cNvPr>
-          <p:cNvPicPr>
-            <a:picLocks noChangeAspect="1"/>
-          </p:cNvPicPr>
-          <p:nvPr/>
-        </p:nvPicPr>
-        <p:blipFill>
-          <a:blip r:embed="rId3"/>
-          <a:stretch>
-            <a:fillRect/>
-          </a:stretch>
-        </p:blipFill>
-        <p:spPr>
-          <a:xfrm rot="-120000">
-            <a:off x="6161565" y="2020930"/>
-            <a:ext cx="2112264" cy="1920240"/>
-          </a:xfrm>
-          <a:prstGeom prst="rect">
-            <a:avLst/>
-          </a:prstGeom>
-        </p:spPr>
-      </p:pic>
-      <p:sp>
-        <p:nvSpPr>
-          <p:cNvPr id="12" name="Class caption"/>
-          <p:cNvSpPr txBox="1"/>
-          <p:nvPr/>
-        </p:nvSpPr>
-        <p:spPr>
-          <a:xfrm rot="-120000">
-            <a:off x="6203050" y="3940446"/>
-            <a:ext cx="2112264" cy="457200"/>
-          </a:xfrm>
-          <a:prstGeom prst="rect">
-            <a:avLst/>
-          </a:prstGeom>
-          <a:noFill/>
-          <a:ln/>
-        </p:spPr>
-        <p:txBody>
-          <a:bodyPr wrap="square" lIns="0" tIns="0" rIns="0" bIns="0" rtlCol="0" anchor="ctr"/>
-          <a:lstStyle/>
-          <a:p>
-            <a:pPr algn="ctr" indent="0" marL="0">
-              <a:buNone/>
-            </a:pPr>
-            <a:r>
-              <a:rPr lang="en-US" sz="1400" i="1" dirty="0">
-                <a:solidFill>
-                  <a:schemeClr val="tx1"/>
-                </a:solidFill>
-                <a:latin typeface="Cambria" pitchFamily="34" charset="0"/>
-                <a:ea typeface="Cambria" pitchFamily="34" charset="-122"/>
-                <a:cs typeface="Cambria" pitchFamily="34" charset="-120"/>
-              </a:rPr>
-              <a:t>Our Class</a:t>
             </a:r>
             <a:endParaRPr lang="en-US" sz="1400" dirty="0"/>
           </a:p>
@@ -2852,7 +2764,7 @@
           <a:bodyPr wrap="square" lIns="0" tIns="0" rIns="0" bIns="0" rtlCol="0" anchor="b"/>
           <a:lstStyle/>
           <a:p>
-            <a:pPr indent="0" marL="0">
+            <a:pPr algn="l" indent="0" marL="0">
               <a:buNone/>
             </a:pPr>
             <a:r>
@@ -2907,7 +2819,7 @@
       </p:sp>
       <p:sp>
         <p:nvSpPr>
-          <p:cNvPr id="4" name="Classroom frame"/>
+          <p:cNvPr id="4" name="Homework frame"/>
           <p:cNvSpPr/>
           <p:nvPr/>
         </p:nvSpPr>
@@ -2934,7 +2846,7 @@
       </p:sp>
       <p:pic>
         <p:nvPicPr>
-          <p:cNvPr id="5" name="Classroom photo" descr="Her classroom (you could take a new photo of it)">    </p:cNvPr>
+          <p:cNvPr id="5" name="Homework photo" descr="Pencil and notebook (homework)">    </p:cNvPr>
           <p:cNvPicPr>
             <a:picLocks noChangeAspect="1"/>
           </p:cNvPicPr>
@@ -2958,7 +2870,7 @@
       </p:pic>
       <p:sp>
         <p:nvSpPr>
-          <p:cNvPr id="6" name="Classroom caption"/>
+          <p:cNvPr id="6" name="Homework caption"/>
           <p:cNvSpPr txBox="1"/>
           <p:nvPr/>
         </p:nvSpPr>
@@ -2989,7 +2901,7 @@
                 <a:ea typeface="Cambria" pitchFamily="34" charset="-122"/>
                 <a:cs typeface="Cambria" pitchFamily="34" charset="-120"/>
               </a:rPr>
-              <a:t>Mrs. Teske's Classroom</a:t>
+              <a:t>Homework &amp; Hard Tests</a:t>
             </a:r>
             <a:endParaRPr lang="en-US" sz="1400" dirty="0"/>
           </a:p>
@@ -3043,7 +2955,7 @@
           <a:bodyPr wrap="square" lIns="0" tIns="0" rIns="0" bIns="0" rtlCol="0" anchor="b"/>
           <a:lstStyle/>
           <a:p>
-            <a:pPr indent="0" marL="0">
+            <a:pPr algn="l" indent="0" marL="0">
               <a:buNone/>
             </a:pPr>
             <a:r>
@@ -3104,8 +3016,8 @@
         </p:nvSpPr>
         <p:spPr>
           <a:xfrm rot="-180000">
-            <a:off x="4160520" y="1179576"/>
-            <a:ext cx="2194560" cy="2852928"/>
+            <a:off x="4206240" y="1019556"/>
+            <a:ext cx="2103120" cy="3172968"/>
           </a:xfrm>
           <a:prstGeom prst="rect">
             <a:avLst/>
@@ -3139,8 +3051,8 @@
         </p:blipFill>
         <p:spPr>
           <a:xfrm rot="-180000">
-            <a:off x="4261155" y="1289542"/>
-            <a:ext cx="1975104" cy="2286000"/>
+            <a:off x="4306875" y="1129522"/>
+            <a:ext cx="1883664" cy="2606040"/>
           </a:xfrm>
           <a:prstGeom prst="rect">
             <a:avLst/>
@@ -3155,8 +3067,8 @@
         </p:nvSpPr>
         <p:spPr>
           <a:xfrm rot="-180000">
-            <a:off x="4332939" y="3573662"/>
-            <a:ext cx="1975104" cy="457200"/>
+            <a:off x="4387034" y="3733463"/>
+            <a:ext cx="1883664" cy="457200"/>
           </a:xfrm>
           <a:prstGeom prst="rect">
             <a:avLst/>
@@ -3194,8 +3106,8 @@
         </p:nvSpPr>
         <p:spPr>
           <a:xfrm rot="180000">
-            <a:off x="6355080" y="1088136"/>
-            <a:ext cx="2194560" cy="2852928"/>
+            <a:off x="6355080" y="928116"/>
+            <a:ext cx="2103120" cy="3172968"/>
           </a:xfrm>
           <a:prstGeom prst="rect">
             <a:avLst/>
@@ -3229,8 +3141,8 @@
         </p:blipFill>
         <p:spPr>
           <a:xfrm rot="180000">
-            <a:off x="6473901" y="1198102"/>
-            <a:ext cx="1975104" cy="2286000"/>
+            <a:off x="6473901" y="1038082"/>
+            <a:ext cx="1883664" cy="2606040"/>
           </a:xfrm>
           <a:prstGeom prst="rect">
             <a:avLst/>
@@ -3245,8 +3157,8 @@
         </p:nvSpPr>
         <p:spPr>
           <a:xfrm rot="180000">
-            <a:off x="6402117" y="3482222"/>
-            <a:ext cx="1975104" cy="457200"/>
+            <a:off x="6393742" y="3642023"/>
+            <a:ext cx="1883664" cy="457200"/>
           </a:xfrm>
           <a:prstGeom prst="rect">
             <a:avLst/>
@@ -3362,7 +3274,7 @@
           <a:bodyPr wrap="square" lIns="0" tIns="0" rIns="0" bIns="0" rtlCol="0" anchor="t"/>
           <a:lstStyle/>
           <a:p>
-            <a:pPr indent="0" marL="0">
+            <a:pPr algn="l" indent="0" marL="0">
               <a:buNone/>
             </a:pPr>
             <a:r>
@@ -3385,8 +3297,8 @@
         </p:nvSpPr>
         <p:spPr>
           <a:xfrm rot="-120000">
-            <a:off x="1508760" y="973836"/>
-            <a:ext cx="2468880" cy="3172968"/>
+            <a:off x="1508760" y="1133856"/>
+            <a:ext cx="2468880" cy="2852928"/>
           </a:xfrm>
           <a:prstGeom prst="rect">
             <a:avLst/>
@@ -3420,8 +3332,8 @@
         </p:blipFill>
         <p:spPr>
           <a:xfrm rot="-120000">
-            <a:off x="1612425" y="1083670"/>
-            <a:ext cx="2249424" cy="2606040"/>
+            <a:off x="1612425" y="1243690"/>
+            <a:ext cx="2249424" cy="2286000"/>
           </a:xfrm>
           <a:prstGeom prst="rect">
             <a:avLst/>
@@ -3436,7 +3348,7 @@
         </p:nvSpPr>
         <p:spPr>
           <a:xfrm rot="-120000">
-            <a:off x="1665877" y="3688777"/>
+            <a:off x="1660293" y="3528854"/>
             <a:ext cx="2249424" cy="457200"/>
           </a:xfrm>
           <a:prstGeom prst="rect">

</xml_diff>

<commit_message>
Caption the last slide's photo as Mrs. Teske and her husband
Co-Authored-By: Claude Opus 5.5 <noreply@anthropic.com>
Claude-Session: https://claude.ai/code/session_01XxaKdzJdgg9PZDJGp43nnJ
</commit_message>
<xml_diff>
--- a/tribute-speech/Tribute_Speech_Mrs_Teske.pptx
+++ b/tribute-speech/Tribute_Speech_Mrs_Teske.pptx
@@ -112,12 +112,12 @@
   <p:extLst>
     <p:ext uri="{521415D9-36F7-43E2-AB2F-B90AF26B5E84}">
       <p14:sectionLst xmlns:p14="http://schemas.microsoft.com/office/powerpoint/2010/main">
-        <p14:section name="Introduction" id="{4275f228-4ea9-50d4-9c02-1ff1dde0f13a}">
+        <p14:section name="Introduction" id="{f5c958ec-47ec-81d7-06b5-3b785861fa5e}">
           <p14:sldIdLst>
             <p14:sldId id="256"/>
           </p14:sldIdLst>
         </p14:section>
-        <p14:section name="Body" id="{cfe2fcc6-a71e-4fc1-4465-c9ae59b52d11}">
+        <p14:section name="Body" id="{2d3cb345-79bc-fc8f-30ed-6ae6025bf0a7}">
           <p14:sldIdLst>
             <p14:sldId id="257"/>
             <p14:sldId id="258"/>
@@ -125,7 +125,7 @@
             <p14:sldId id="260"/>
           </p14:sldIdLst>
         </p14:section>
-        <p14:section name="Conclusion" id="{ca5b5e8b-6659-b67d-a8ce-bfc9dd34a0d8}">
+        <p14:section name="Conclusion" id="{9ed82e7e-fc3e-e776-b77b-dbb8fbc80aa4}">
           <p14:sldIdLst>
             <p14:sldId id="261"/>
           </p14:sldIdLst>
@@ -3318,7 +3318,7 @@
       </p:sp>
       <p:pic>
         <p:nvPicPr>
-          <p:cNvPr id="5" name="Thanks photo" descr="Mrs. Teske (or you with her)">    </p:cNvPr>
+          <p:cNvPr id="5" name="Thanks photo" descr="Mrs. Teske and her husband">    </p:cNvPr>
           <p:cNvPicPr>
             <a:picLocks noChangeAspect="1"/>
           </p:cNvPicPr>
@@ -3373,7 +3373,7 @@
                 <a:ea typeface="Cambria" pitchFamily="34" charset="-122"/>
                 <a:cs typeface="Cambria" pitchFamily="34" charset="-120"/>
               </a:rPr>
-              <a:t>Mrs. Teske</a:t>
+              <a:t>Mrs. Teske &amp; Her Husband</a:t>
             </a:r>
             <a:endParaRPr lang="en-US" sz="1400" dirty="0"/>
           </a:p>

</xml_diff>